<commit_message>
Add per-item infographic slide prototype (9-slide test) and fix overflow bug
Test deck (3 items per business type) uses a breadcrumb header, left-side
item detail block, and a right-side source-to-rationale infographic
(timeline cards -> synthesis box). Fixed a layout bug where the summary
box's text could overflow past the slide edge when only 2 source cards
were present: card area is now sized to actual content instead of an
even fixed split, and the synthesis box gets priority space with a
computed (not PowerPoint-autofit) font size guaranteed to fit.

Co-Authored-By: Claude Sonnet 5 <noreply@anthropic.com>
Claude-Session: https://claude.ai/code/session_014jfeC88e2RPvHxCxXJbk9x
</commit_message>
<xml_diff>
--- a/checklist/감리_점검항목_해설서.pptx
+++ b/checklist/감리_점검항목_해설서.pptx
@@ -5,8 +5,7 @@
     <p:sldMasterId id="2147483648" r:id="rId1"/>
   </p:sldMasterIdLst>
   <p:sldIdLst>
-    <p:sldId id="256" r:id="rId2"/>
-    <p:sldId id="257" r:id="rId3"/>
+    <p:sldId id="257" r:id="rId2"/>
   </p:sldIdLst>
   <p:sldSz cx="12192000" cy="6858000"/>
   <p:notesSz cx="6858000" cy="9144000"/>
@@ -3075,340 +3074,6 @@
 </file>
 
 <file path=ppt/slides/slide1.xml><?xml version="1.0" encoding="utf-8"?>
-<p:sld xmlns:a="http://schemas.openxmlformats.org/drawingml/2006/main" xmlns:r="http://schemas.openxmlformats.org/officeDocument/2006/relationships" xmlns:p="http://schemas.openxmlformats.org/presentationml/2006/main">
-  <p:cSld>
-    <p:bg>
-      <p:bgPr>
-        <a:solidFill>
-          <a:srgbClr val="1F3864"/>
-        </a:solidFill>
-        <a:effectLst/>
-      </p:bgPr>
-    </p:bg>
-    <p:spTree>
-      <p:nvGrpSpPr>
-        <p:cNvPr id="1" name=""/>
-        <p:cNvGrpSpPr/>
-        <p:nvPr/>
-      </p:nvGrpSpPr>
-      <p:grpSpPr>
-        <a:xfrm>
-          <a:off x="0" y="0"/>
-          <a:ext cx="0" cy="0"/>
-          <a:chOff x="0" y="0"/>
-          <a:chExt cx="0" cy="0"/>
-        </a:xfrm>
-      </p:grpSpPr>
-      <p:sp>
-        <p:nvSpPr>
-          <p:cNvPr id="2" name="Rectangle 1"/>
-          <p:cNvSpPr/>
-          <p:nvPr/>
-        </p:nvSpPr>
-        <p:spPr>
-          <a:xfrm>
-            <a:off x="0" y="4480560"/>
-            <a:ext cx="12191695" cy="54864"/>
-          </a:xfrm>
-          <a:prstGeom prst="rect">
-            <a:avLst/>
-          </a:prstGeom>
-          <a:solidFill>
-            <a:srgbClr val="E07A2C"/>
-          </a:solidFill>
-          <a:ln>
-            <a:noFill/>
-          </a:ln>
-          <a:effectLst/>
-        </p:spPr>
-        <p:style>
-          <a:lnRef idx="1">
-            <a:schemeClr val="accent1"/>
-          </a:lnRef>
-          <a:fillRef idx="3">
-            <a:schemeClr val="accent1"/>
-          </a:fillRef>
-          <a:effectRef idx="2">
-            <a:schemeClr val="accent1"/>
-          </a:effectRef>
-          <a:fontRef idx="minor">
-            <a:schemeClr val="lt1"/>
-          </a:fontRef>
-        </p:style>
-        <p:txBody>
-          <a:bodyPr rtlCol="0" anchor="ctr"/>
-          <a:lstStyle/>
-          <a:p>
-            <a:pPr algn="ctr"/>
-            <a:endParaRPr/>
-          </a:p>
-        </p:txBody>
-      </p:sp>
-      <p:sp>
-        <p:nvSpPr>
-          <p:cNvPr id="4" name="TextBox 3"/>
-          <p:cNvSpPr txBox="1"/>
-          <p:nvPr/>
-        </p:nvSpPr>
-        <p:spPr>
-          <a:xfrm>
-            <a:off x="777240" y="1844679"/>
-            <a:ext cx="10607040" cy="1283108"/>
-          </a:xfrm>
-          <a:prstGeom prst="rect">
-            <a:avLst/>
-          </a:prstGeom>
-          <a:noFill/>
-        </p:spPr>
-        <p:txBody>
-          <a:bodyPr wrap="square" lIns="0" tIns="0" rIns="0" bIns="0" anchor="t">
-            <a:spAutoFit/>
-          </a:bodyPr>
-          <a:lstStyle/>
-          <a:p>
-            <a:pPr algn="l">
-              <a:lnSpc>
-                <a:spcPct val="115000"/>
-              </a:lnSpc>
-            </a:pPr>
-            <a:r>
-              <a:rPr sz="3800" b="1" dirty="0" err="1">
-                <a:solidFill>
-                  <a:srgbClr val="FFFFFF"/>
-                </a:solidFill>
-                <a:latin typeface="맑은 고딕"/>
-              </a:rPr>
-              <a:t>클라우드</a:t>
-            </a:r>
-            <a:r>
-              <a:rPr sz="3800" b="1" dirty="0">
-                <a:solidFill>
-                  <a:srgbClr val="FFFFFF"/>
-                </a:solidFill>
-                <a:latin typeface="맑은 고딕"/>
-              </a:rPr>
-              <a:t> </a:t>
-            </a:r>
-            <a:r>
-              <a:rPr sz="3800" b="1" dirty="0" err="1">
-                <a:solidFill>
-                  <a:srgbClr val="FFFFFF"/>
-                </a:solidFill>
-                <a:latin typeface="맑은 고딕"/>
-              </a:rPr>
-              <a:t>전환</a:t>
-            </a:r>
-            <a:r>
-              <a:rPr sz="3800" b="1" dirty="0">
-                <a:solidFill>
-                  <a:srgbClr val="FFFFFF"/>
-                </a:solidFill>
-                <a:latin typeface="맑은 고딕"/>
-              </a:rPr>
-              <a:t> · </a:t>
-            </a:r>
-            <a:r>
-              <a:rPr sz="3800" b="1" dirty="0" err="1">
-                <a:solidFill>
-                  <a:srgbClr val="FFFFFF"/>
-                </a:solidFill>
-                <a:latin typeface="맑은 고딕"/>
-              </a:rPr>
-              <a:t>운영</a:t>
-            </a:r>
-            <a:r>
-              <a:rPr sz="3800" b="1" dirty="0">
-                <a:solidFill>
-                  <a:srgbClr val="FFFFFF"/>
-                </a:solidFill>
-                <a:latin typeface="맑은 고딕"/>
-              </a:rPr>
-              <a:t> 및 </a:t>
-            </a:r>
-            <a:r>
-              <a:rPr sz="3800" b="1" dirty="0" err="1">
-                <a:solidFill>
-                  <a:srgbClr val="FFFFFF"/>
-                </a:solidFill>
-                <a:latin typeface="맑은 고딕"/>
-              </a:rPr>
-              <a:t>유지관리</a:t>
-            </a:r>
-            <a:r>
-              <a:rPr sz="3800" b="1" dirty="0">
-                <a:solidFill>
-                  <a:srgbClr val="FFFFFF"/>
-                </a:solidFill>
-                <a:latin typeface="맑은 고딕"/>
-              </a:rPr>
-              <a:t> · </a:t>
-            </a:r>
-            <a:r>
-              <a:rPr sz="3800" b="1" dirty="0" err="1">
-                <a:solidFill>
-                  <a:srgbClr val="FFFFFF"/>
-                </a:solidFill>
-                <a:latin typeface="맑은 고딕"/>
-              </a:rPr>
-              <a:t>생성형</a:t>
-            </a:r>
-            <a:r>
-              <a:rPr sz="3800" b="1" dirty="0">
-                <a:solidFill>
-                  <a:srgbClr val="FFFFFF"/>
-                </a:solidFill>
-                <a:latin typeface="맑은 고딕"/>
-              </a:rPr>
-              <a:t> AI</a:t>
-            </a:r>
-          </a:p>
-          <a:p>
-            <a:pPr algn="l">
-              <a:lnSpc>
-                <a:spcPct val="115000"/>
-              </a:lnSpc>
-            </a:pPr>
-            <a:r>
-              <a:rPr sz="3800" b="1" dirty="0" err="1">
-                <a:solidFill>
-                  <a:srgbClr val="FFFFFF"/>
-                </a:solidFill>
-                <a:latin typeface="맑은 고딕"/>
-              </a:rPr>
-              <a:t>감리</a:t>
-            </a:r>
-            <a:r>
-              <a:rPr sz="3800" b="1" dirty="0">
-                <a:solidFill>
-                  <a:srgbClr val="FFFFFF"/>
-                </a:solidFill>
-                <a:latin typeface="맑은 고딕"/>
-              </a:rPr>
-              <a:t> </a:t>
-            </a:r>
-            <a:r>
-              <a:rPr sz="3800" b="1" dirty="0" err="1">
-                <a:solidFill>
-                  <a:srgbClr val="FFFFFF"/>
-                </a:solidFill>
-                <a:latin typeface="맑은 고딕"/>
-              </a:rPr>
-              <a:t>점검항목</a:t>
-            </a:r>
-            <a:r>
-              <a:rPr sz="3800" b="1" dirty="0">
-                <a:solidFill>
-                  <a:srgbClr val="FFFFFF"/>
-                </a:solidFill>
-                <a:latin typeface="맑은 고딕"/>
-              </a:rPr>
-              <a:t>  </a:t>
-            </a:r>
-            <a:r>
-              <a:rPr sz="3800" b="1" dirty="0" err="1">
-                <a:solidFill>
-                  <a:srgbClr val="FFFFFF"/>
-                </a:solidFill>
-                <a:latin typeface="맑은 고딕"/>
-              </a:rPr>
-              <a:t>해설서</a:t>
-            </a:r>
-            <a:endParaRPr sz="3800" b="1" dirty="0">
-              <a:solidFill>
-                <a:srgbClr val="FFFFFF"/>
-              </a:solidFill>
-              <a:latin typeface="맑은 고딕"/>
-            </a:endParaRPr>
-          </a:p>
-        </p:txBody>
-      </p:sp>
-      <p:sp>
-        <p:nvSpPr>
-          <p:cNvPr id="5" name="TextBox 4"/>
-          <p:cNvSpPr txBox="1"/>
-          <p:nvPr/>
-        </p:nvSpPr>
-        <p:spPr>
-          <a:xfrm>
-            <a:off x="822960" y="4709160"/>
-            <a:ext cx="10058400" cy="457200"/>
-          </a:xfrm>
-          <a:prstGeom prst="rect">
-            <a:avLst/>
-          </a:prstGeom>
-          <a:noFill/>
-        </p:spPr>
-        <p:txBody>
-          <a:bodyPr wrap="square" lIns="0" tIns="0" rIns="0" bIns="0" anchor="t">
-            <a:spAutoFit/>
-          </a:bodyPr>
-          <a:lstStyle/>
-          <a:p>
-            <a:pPr algn="l">
-              <a:lnSpc>
-                <a:spcPct val="100000"/>
-              </a:lnSpc>
-            </a:pPr>
-            <a:r>
-              <a:rPr sz="1600" b="0">
-                <a:solidFill>
-                  <a:srgbClr val="D8E0EC"/>
-                </a:solidFill>
-                <a:latin typeface="맑은 고딕"/>
-              </a:rPr>
-              <a:t>모든 점검항목에 법령·지침·표준 등 출처와 근거를 부여하여 감리의 객관성과 신뢰성을 확보</a:t>
-            </a:r>
-          </a:p>
-        </p:txBody>
-      </p:sp>
-      <p:sp>
-        <p:nvSpPr>
-          <p:cNvPr id="6" name="TextBox 5"/>
-          <p:cNvSpPr txBox="1"/>
-          <p:nvPr/>
-        </p:nvSpPr>
-        <p:spPr>
-          <a:xfrm>
-            <a:off x="822960" y="6172200"/>
-            <a:ext cx="5486400" cy="365760"/>
-          </a:xfrm>
-          <a:prstGeom prst="rect">
-            <a:avLst/>
-          </a:prstGeom>
-          <a:noFill/>
-        </p:spPr>
-        <p:txBody>
-          <a:bodyPr wrap="square" lIns="0" tIns="0" rIns="0" bIns="0" anchor="t">
-            <a:spAutoFit/>
-          </a:bodyPr>
-          <a:lstStyle/>
-          <a:p>
-            <a:pPr algn="l">
-              <a:lnSpc>
-                <a:spcPct val="100000"/>
-              </a:lnSpc>
-            </a:pPr>
-            <a:r>
-              <a:rPr sz="1200" b="0">
-                <a:solidFill>
-                  <a:srgbClr val="9AADC7"/>
-                </a:solidFill>
-                <a:latin typeface="맑은 고딕"/>
-              </a:rPr>
-              <a:t>2026. 08</a:t>
-            </a:r>
-          </a:p>
-        </p:txBody>
-      </p:sp>
-    </p:spTree>
-  </p:cSld>
-  <p:clrMapOvr>
-    <a:masterClrMapping/>
-  </p:clrMapOvr>
-</p:sld>
-</file>
-
-<file path=ppt/slides/slide2.xml><?xml version="1.0" encoding="utf-8"?>
 <p:sld xmlns:a="http://schemas.openxmlformats.org/drawingml/2006/main" xmlns:r="http://schemas.openxmlformats.org/officeDocument/2006/relationships" xmlns:p="http://schemas.openxmlformats.org/presentationml/2006/main">
   <p:cSld>
     <p:bg>

</xml_diff>